<commit_message>
OCEO: propaga a logo melhorada por toda a identidade e materiais
- identidade-visual/LOGO-OCEO.png e LOGO-OCEO-mark.png regeradas em alta
  resolucao (transparente), com o mesmo tratamento do JPG (nitidez em duas
  escalas, contraste/saturacao moderados, sem estourar o especular do
  cromo) — script melhorar-logo-transparente.py.
- Apresentacao (pptx): a logo volta a aparecer nos 5 abre-pilar (as
  "cinco modalidades" GC/GF/GJ/GM/GI), alem da capa e do fecho.
- Video do business plan: logo grande e watermark trocados, video
  re-renderizado (com e sem audio).
- Documento de registro de obra literaria, "OCEO - Os 5 Pilares.pdf" e as
  duas versoes do pitch de BI (interna e externa): recapa/recover com a
  logo nova.
- pitch-bi/ (dado real de cliente) segue fora da sincronia, como definido.

Co-Authored-By: Claude Sonnet 5 <noreply@anthropic.com>
</commit_message>
<xml_diff>
--- a/Projetos Gsena Tec/oceo/apresentacao/OCEO - A Obra Completa (apresentacao).pptx
+++ b/Projetos Gsena Tec/oceo/apresentacao/OCEO - A Obra Completa (apresentacao).pptx
@@ -6226,15 +6226,39 @@
           </a:p>
         </p:txBody>
       </p:sp>
-      <p:sp>
-        <p:nvSpPr>
-          <p:cNvPr id="3" name="Rectangle 2"/>
+      <p:pic>
+        <p:nvPicPr>
+          <p:cNvPr id="3" name="Picture 2" descr="LOGO-OCEO.png"/>
+          <p:cNvPicPr>
+            <a:picLocks noChangeAspect="1"/>
+          </p:cNvPicPr>
+          <p:nvPr/>
+        </p:nvPicPr>
+        <p:blipFill>
+          <a:blip r:embed="rId2"/>
+          <a:stretch>
+            <a:fillRect/>
+          </a:stretch>
+        </p:blipFill>
+        <p:spPr>
+          <a:xfrm>
+            <a:off x="868680" y="777240"/>
+            <a:ext cx="2468880" cy="1991869"/>
+          </a:xfrm>
+          <a:prstGeom prst="rect">
+            <a:avLst/>
+          </a:prstGeom>
+        </p:spPr>
+      </p:pic>
+      <p:sp>
+        <p:nvSpPr>
+          <p:cNvPr id="4" name="Rectangle 3"/>
           <p:cNvSpPr/>
           <p:nvPr/>
         </p:nvSpPr>
         <p:spPr>
           <a:xfrm>
-            <a:off x="914400" y="2651760"/>
+            <a:off x="914400" y="3977639"/>
             <a:ext cx="2011680" cy="38100"/>
           </a:xfrm>
           <a:prstGeom prst="rect">
@@ -6272,13 +6296,13 @@
       </p:sp>
       <p:sp>
         <p:nvSpPr>
-          <p:cNvPr id="4" name="TextBox 3"/>
+          <p:cNvPr id="5" name="TextBox 4"/>
           <p:cNvSpPr txBox="1"/>
           <p:nvPr/>
         </p:nvSpPr>
         <p:spPr>
           <a:xfrm>
-            <a:off x="896112" y="2880360"/>
+            <a:off x="896112" y="4206240"/>
             <a:ext cx="10058400" cy="2194560"/>
           </a:xfrm>
           <a:prstGeom prst="rect">
@@ -6362,7 +6386,7 @@
                       </p:stCondLst>
                       <p:childTnLst>
                         <p:par>
-                          <p:cTn id="6" presetID="10" presetClass="entr" presetSubtype="0" fill="hold" grpId="0" nodeType="afterEffect">
+                          <p:cTn id="8" presetID="23" presetClass="entr" presetSubtype="16" fill="hold" grpId="0" nodeType="afterEffect">
                             <p:stCondLst>
                               <p:cond delay="0"/>
                             </p:stCondLst>
@@ -6375,7 +6399,88 @@
                                     </p:stCondLst>
                                   </p:cTn>
                                   <p:tgtEl>
-                                    <p:spTgt spid="4"/>
+                                    <p:spTgt spid="3"/>
+                                  </p:tgtEl>
+                                  <p:attrNameLst>
+                                    <p:attrName>style.visibility</p:attrName>
+                                  </p:attrNameLst>
+                                </p:cBhvr>
+                                <p:to>
+                                  <p:strVal val="visible"/>
+                                </p:to>
+                              </p:set>
+                              <p:anim calcmode="lin" valueType="num">
+                                <p:cBhvr additive="base">
+                                  <p:cTn id="5" dur="600" fill="hold"/>
+                                  <p:tgtEl>
+                                    <p:spTgt spid="3"/>
+                                  </p:tgtEl>
+                                  <p:attrNameLst>
+                                    <p:attrName>ppt_w</p:attrName>
+                                  </p:attrNameLst>
+                                </p:cBhvr>
+                                <p:tavLst>
+                                  <p:tav tm="0">
+                                    <p:val>
+                                      <p:fltVal val="0.3"/>
+                                    </p:val>
+                                  </p:tav>
+                                  <p:tav tm="100000">
+                                    <p:val>
+                                      <p:fltVal val="1"/>
+                                    </p:val>
+                                  </p:tav>
+                                </p:tavLst>
+                              </p:anim>
+                              <p:anim calcmode="lin" valueType="num">
+                                <p:cBhvr additive="base">
+                                  <p:cTn id="6" dur="600" fill="hold"/>
+                                  <p:tgtEl>
+                                    <p:spTgt spid="3"/>
+                                  </p:tgtEl>
+                                  <p:attrNameLst>
+                                    <p:attrName>ppt_h</p:attrName>
+                                  </p:attrNameLst>
+                                </p:cBhvr>
+                                <p:tavLst>
+                                  <p:tav tm="0">
+                                    <p:val>
+                                      <p:fltVal val="0.3"/>
+                                    </p:val>
+                                  </p:tav>
+                                  <p:tav tm="100000">
+                                    <p:val>
+                                      <p:fltVal val="1"/>
+                                    </p:val>
+                                  </p:tav>
+                                </p:tavLst>
+                              </p:anim>
+                              <p:animEffect transition="in" filter="fade">
+                                <p:cBhvr>
+                                  <p:cTn id="7" dur="600"/>
+                                  <p:tgtEl>
+                                    <p:spTgt spid="3"/>
+                                  </p:tgtEl>
+                                </p:cBhvr>
+                              </p:animEffect>
+                            </p:childTnLst>
+                          </p:cTn>
+                        </p:par>
+                        <p:par>
+                          <p:cTn id="11" presetID="10" presetClass="entr" presetSubtype="0" fill="hold" grpId="0" nodeType="afterEffect">
+                            <p:stCondLst>
+                              <p:cond delay="350"/>
+                            </p:stCondLst>
+                            <p:childTnLst>
+                              <p:set>
+                                <p:cBhvr>
+                                  <p:cTn id="9" dur="1" fill="hold">
+                                    <p:stCondLst>
+                                      <p:cond delay="0"/>
+                                    </p:stCondLst>
+                                  </p:cTn>
+                                  <p:tgtEl>
+                                    <p:spTgt spid="5"/>
                                   </p:tgtEl>
                                   <p:attrNameLst>
                                     <p:attrName>style.visibility</p:attrName>
@@ -6387,9 +6492,9 @@
                               </p:set>
                               <p:animEffect transition="in" filter="fade">
                                 <p:cBhvr>
-                                  <p:cTn id="5" dur="400"/>
+                                  <p:cTn id="10" dur="400"/>
                                   <p:tgtEl>
-                                    <p:spTgt spid="4"/>
+                                    <p:spTgt spid="5"/>
                                   </p:tgtEl>
                                 </p:cBhvr>
                               </p:animEffect>
@@ -9234,15 +9339,39 @@
           </a:p>
         </p:txBody>
       </p:sp>
-      <p:sp>
-        <p:nvSpPr>
-          <p:cNvPr id="3" name="Rectangle 2"/>
+      <p:pic>
+        <p:nvPicPr>
+          <p:cNvPr id="3" name="Picture 2" descr="LOGO-OCEO.png"/>
+          <p:cNvPicPr>
+            <a:picLocks noChangeAspect="1"/>
+          </p:cNvPicPr>
+          <p:nvPr/>
+        </p:nvPicPr>
+        <p:blipFill>
+          <a:blip r:embed="rId2"/>
+          <a:stretch>
+            <a:fillRect/>
+          </a:stretch>
+        </p:blipFill>
+        <p:spPr>
+          <a:xfrm>
+            <a:off x="868680" y="777240"/>
+            <a:ext cx="2468880" cy="1991869"/>
+          </a:xfrm>
+          <a:prstGeom prst="rect">
+            <a:avLst/>
+          </a:prstGeom>
+        </p:spPr>
+      </p:pic>
+      <p:sp>
+        <p:nvSpPr>
+          <p:cNvPr id="4" name="Rectangle 3"/>
           <p:cNvSpPr/>
           <p:nvPr/>
         </p:nvSpPr>
         <p:spPr>
           <a:xfrm>
-            <a:off x="914400" y="2651760"/>
+            <a:off x="914400" y="3977639"/>
             <a:ext cx="2011680" cy="38100"/>
           </a:xfrm>
           <a:prstGeom prst="rect">
@@ -9280,13 +9409,13 @@
       </p:sp>
       <p:sp>
         <p:nvSpPr>
-          <p:cNvPr id="4" name="TextBox 3"/>
+          <p:cNvPr id="5" name="TextBox 4"/>
           <p:cNvSpPr txBox="1"/>
           <p:nvPr/>
         </p:nvSpPr>
         <p:spPr>
           <a:xfrm>
-            <a:off x="896112" y="2880360"/>
+            <a:off x="896112" y="4206240"/>
             <a:ext cx="10058400" cy="2194560"/>
           </a:xfrm>
           <a:prstGeom prst="rect">
@@ -9370,7 +9499,7 @@
                       </p:stCondLst>
                       <p:childTnLst>
                         <p:par>
-                          <p:cTn id="6" presetID="10" presetClass="entr" presetSubtype="0" fill="hold" grpId="0" nodeType="afterEffect">
+                          <p:cTn id="8" presetID="23" presetClass="entr" presetSubtype="16" fill="hold" grpId="0" nodeType="afterEffect">
                             <p:stCondLst>
                               <p:cond delay="0"/>
                             </p:stCondLst>
@@ -9383,7 +9512,88 @@
                                     </p:stCondLst>
                                   </p:cTn>
                                   <p:tgtEl>
-                                    <p:spTgt spid="4"/>
+                                    <p:spTgt spid="3"/>
+                                  </p:tgtEl>
+                                  <p:attrNameLst>
+                                    <p:attrName>style.visibility</p:attrName>
+                                  </p:attrNameLst>
+                                </p:cBhvr>
+                                <p:to>
+                                  <p:strVal val="visible"/>
+                                </p:to>
+                              </p:set>
+                              <p:anim calcmode="lin" valueType="num">
+                                <p:cBhvr additive="base">
+                                  <p:cTn id="5" dur="600" fill="hold"/>
+                                  <p:tgtEl>
+                                    <p:spTgt spid="3"/>
+                                  </p:tgtEl>
+                                  <p:attrNameLst>
+                                    <p:attrName>ppt_w</p:attrName>
+                                  </p:attrNameLst>
+                                </p:cBhvr>
+                                <p:tavLst>
+                                  <p:tav tm="0">
+                                    <p:val>
+                                      <p:fltVal val="0.3"/>
+                                    </p:val>
+                                  </p:tav>
+                                  <p:tav tm="100000">
+                                    <p:val>
+                                      <p:fltVal val="1"/>
+                                    </p:val>
+                                  </p:tav>
+                                </p:tavLst>
+                              </p:anim>
+                              <p:anim calcmode="lin" valueType="num">
+                                <p:cBhvr additive="base">
+                                  <p:cTn id="6" dur="600" fill="hold"/>
+                                  <p:tgtEl>
+                                    <p:spTgt spid="3"/>
+                                  </p:tgtEl>
+                                  <p:attrNameLst>
+                                    <p:attrName>ppt_h</p:attrName>
+                                  </p:attrNameLst>
+                                </p:cBhvr>
+                                <p:tavLst>
+                                  <p:tav tm="0">
+                                    <p:val>
+                                      <p:fltVal val="0.3"/>
+                                    </p:val>
+                                  </p:tav>
+                                  <p:tav tm="100000">
+                                    <p:val>
+                                      <p:fltVal val="1"/>
+                                    </p:val>
+                                  </p:tav>
+                                </p:tavLst>
+                              </p:anim>
+                              <p:animEffect transition="in" filter="fade">
+                                <p:cBhvr>
+                                  <p:cTn id="7" dur="600"/>
+                                  <p:tgtEl>
+                                    <p:spTgt spid="3"/>
+                                  </p:tgtEl>
+                                </p:cBhvr>
+                              </p:animEffect>
+                            </p:childTnLst>
+                          </p:cTn>
+                        </p:par>
+                        <p:par>
+                          <p:cTn id="11" presetID="10" presetClass="entr" presetSubtype="0" fill="hold" grpId="0" nodeType="afterEffect">
+                            <p:stCondLst>
+                              <p:cond delay="350"/>
+                            </p:stCondLst>
+                            <p:childTnLst>
+                              <p:set>
+                                <p:cBhvr>
+                                  <p:cTn id="9" dur="1" fill="hold">
+                                    <p:stCondLst>
+                                      <p:cond delay="0"/>
+                                    </p:stCondLst>
+                                  </p:cTn>
+                                  <p:tgtEl>
+                                    <p:spTgt spid="5"/>
                                   </p:tgtEl>
                                   <p:attrNameLst>
                                     <p:attrName>style.visibility</p:attrName>
@@ -9395,9 +9605,9 @@
                               </p:set>
                               <p:animEffect transition="in" filter="fade">
                                 <p:cBhvr>
-                                  <p:cTn id="5" dur="400"/>
+                                  <p:cTn id="10" dur="400"/>
                                   <p:tgtEl>
-                                    <p:spTgt spid="4"/>
+                                    <p:spTgt spid="5"/>
                                   </p:tgtEl>
                                 </p:cBhvr>
                               </p:animEffect>
@@ -11000,15 +11210,39 @@
           </a:p>
         </p:txBody>
       </p:sp>
-      <p:sp>
-        <p:nvSpPr>
-          <p:cNvPr id="3" name="Rectangle 2"/>
+      <p:pic>
+        <p:nvPicPr>
+          <p:cNvPr id="3" name="Picture 2" descr="LOGO-OCEO.png"/>
+          <p:cNvPicPr>
+            <a:picLocks noChangeAspect="1"/>
+          </p:cNvPicPr>
+          <p:nvPr/>
+        </p:nvPicPr>
+        <p:blipFill>
+          <a:blip r:embed="rId2"/>
+          <a:stretch>
+            <a:fillRect/>
+          </a:stretch>
+        </p:blipFill>
+        <p:spPr>
+          <a:xfrm>
+            <a:off x="868680" y="777240"/>
+            <a:ext cx="2468880" cy="1991869"/>
+          </a:xfrm>
+          <a:prstGeom prst="rect">
+            <a:avLst/>
+          </a:prstGeom>
+        </p:spPr>
+      </p:pic>
+      <p:sp>
+        <p:nvSpPr>
+          <p:cNvPr id="4" name="Rectangle 3"/>
           <p:cNvSpPr/>
           <p:nvPr/>
         </p:nvSpPr>
         <p:spPr>
           <a:xfrm>
-            <a:off x="914400" y="2651760"/>
+            <a:off x="914400" y="3977639"/>
             <a:ext cx="2011680" cy="38100"/>
           </a:xfrm>
           <a:prstGeom prst="rect">
@@ -11046,13 +11280,13 @@
       </p:sp>
       <p:sp>
         <p:nvSpPr>
-          <p:cNvPr id="4" name="TextBox 3"/>
+          <p:cNvPr id="5" name="TextBox 4"/>
           <p:cNvSpPr txBox="1"/>
           <p:nvPr/>
         </p:nvSpPr>
         <p:spPr>
           <a:xfrm>
-            <a:off x="896112" y="2880360"/>
+            <a:off x="896112" y="4206240"/>
             <a:ext cx="10058400" cy="2194560"/>
           </a:xfrm>
           <a:prstGeom prst="rect">
@@ -11136,7 +11370,7 @@
                       </p:stCondLst>
                       <p:childTnLst>
                         <p:par>
-                          <p:cTn id="6" presetID="10" presetClass="entr" presetSubtype="0" fill="hold" grpId="0" nodeType="afterEffect">
+                          <p:cTn id="8" presetID="23" presetClass="entr" presetSubtype="16" fill="hold" grpId="0" nodeType="afterEffect">
                             <p:stCondLst>
                               <p:cond delay="0"/>
                             </p:stCondLst>
@@ -11149,7 +11383,88 @@
                                     </p:stCondLst>
                                   </p:cTn>
                                   <p:tgtEl>
-                                    <p:spTgt spid="4"/>
+                                    <p:spTgt spid="3"/>
+                                  </p:tgtEl>
+                                  <p:attrNameLst>
+                                    <p:attrName>style.visibility</p:attrName>
+                                  </p:attrNameLst>
+                                </p:cBhvr>
+                                <p:to>
+                                  <p:strVal val="visible"/>
+                                </p:to>
+                              </p:set>
+                              <p:anim calcmode="lin" valueType="num">
+                                <p:cBhvr additive="base">
+                                  <p:cTn id="5" dur="600" fill="hold"/>
+                                  <p:tgtEl>
+                                    <p:spTgt spid="3"/>
+                                  </p:tgtEl>
+                                  <p:attrNameLst>
+                                    <p:attrName>ppt_w</p:attrName>
+                                  </p:attrNameLst>
+                                </p:cBhvr>
+                                <p:tavLst>
+                                  <p:tav tm="0">
+                                    <p:val>
+                                      <p:fltVal val="0.3"/>
+                                    </p:val>
+                                  </p:tav>
+                                  <p:tav tm="100000">
+                                    <p:val>
+                                      <p:fltVal val="1"/>
+                                    </p:val>
+                                  </p:tav>
+                                </p:tavLst>
+                              </p:anim>
+                              <p:anim calcmode="lin" valueType="num">
+                                <p:cBhvr additive="base">
+                                  <p:cTn id="6" dur="600" fill="hold"/>
+                                  <p:tgtEl>
+                                    <p:spTgt spid="3"/>
+                                  </p:tgtEl>
+                                  <p:attrNameLst>
+                                    <p:attrName>ppt_h</p:attrName>
+                                  </p:attrNameLst>
+                                </p:cBhvr>
+                                <p:tavLst>
+                                  <p:tav tm="0">
+                                    <p:val>
+                                      <p:fltVal val="0.3"/>
+                                    </p:val>
+                                  </p:tav>
+                                  <p:tav tm="100000">
+                                    <p:val>
+                                      <p:fltVal val="1"/>
+                                    </p:val>
+                                  </p:tav>
+                                </p:tavLst>
+                              </p:anim>
+                              <p:animEffect transition="in" filter="fade">
+                                <p:cBhvr>
+                                  <p:cTn id="7" dur="600"/>
+                                  <p:tgtEl>
+                                    <p:spTgt spid="3"/>
+                                  </p:tgtEl>
+                                </p:cBhvr>
+                              </p:animEffect>
+                            </p:childTnLst>
+                          </p:cTn>
+                        </p:par>
+                        <p:par>
+                          <p:cTn id="11" presetID="10" presetClass="entr" presetSubtype="0" fill="hold" grpId="0" nodeType="afterEffect">
+                            <p:stCondLst>
+                              <p:cond delay="350"/>
+                            </p:stCondLst>
+                            <p:childTnLst>
+                              <p:set>
+                                <p:cBhvr>
+                                  <p:cTn id="9" dur="1" fill="hold">
+                                    <p:stCondLst>
+                                      <p:cond delay="0"/>
+                                    </p:stCondLst>
+                                  </p:cTn>
+                                  <p:tgtEl>
+                                    <p:spTgt spid="5"/>
                                   </p:tgtEl>
                                   <p:attrNameLst>
                                     <p:attrName>style.visibility</p:attrName>
@@ -11161,9 +11476,9 @@
                               </p:set>
                               <p:animEffect transition="in" filter="fade">
                                 <p:cBhvr>
-                                  <p:cTn id="5" dur="400"/>
+                                  <p:cTn id="10" dur="400"/>
                                   <p:tgtEl>
-                                    <p:spTgt spid="4"/>
+                                    <p:spTgt spid="5"/>
                                   </p:tgtEl>
                                 </p:cBhvr>
                               </p:animEffect>
@@ -12202,15 +12517,39 @@
           </a:p>
         </p:txBody>
       </p:sp>
-      <p:sp>
-        <p:nvSpPr>
-          <p:cNvPr id="3" name="Rectangle 2"/>
+      <p:pic>
+        <p:nvPicPr>
+          <p:cNvPr id="3" name="Picture 2" descr="LOGO-OCEO.png"/>
+          <p:cNvPicPr>
+            <a:picLocks noChangeAspect="1"/>
+          </p:cNvPicPr>
+          <p:nvPr/>
+        </p:nvPicPr>
+        <p:blipFill>
+          <a:blip r:embed="rId2"/>
+          <a:stretch>
+            <a:fillRect/>
+          </a:stretch>
+        </p:blipFill>
+        <p:spPr>
+          <a:xfrm>
+            <a:off x="868680" y="777240"/>
+            <a:ext cx="2468880" cy="1991869"/>
+          </a:xfrm>
+          <a:prstGeom prst="rect">
+            <a:avLst/>
+          </a:prstGeom>
+        </p:spPr>
+      </p:pic>
+      <p:sp>
+        <p:nvSpPr>
+          <p:cNvPr id="4" name="Rectangle 3"/>
           <p:cNvSpPr/>
           <p:nvPr/>
         </p:nvSpPr>
         <p:spPr>
           <a:xfrm>
-            <a:off x="914400" y="2651760"/>
+            <a:off x="914400" y="3977639"/>
             <a:ext cx="2011680" cy="38100"/>
           </a:xfrm>
           <a:prstGeom prst="rect">
@@ -12248,13 +12587,13 @@
       </p:sp>
       <p:sp>
         <p:nvSpPr>
-          <p:cNvPr id="4" name="TextBox 3"/>
+          <p:cNvPr id="5" name="TextBox 4"/>
           <p:cNvSpPr txBox="1"/>
           <p:nvPr/>
         </p:nvSpPr>
         <p:spPr>
           <a:xfrm>
-            <a:off x="896112" y="2880360"/>
+            <a:off x="896112" y="4206240"/>
             <a:ext cx="10058400" cy="2194560"/>
           </a:xfrm>
           <a:prstGeom prst="rect">
@@ -12338,7 +12677,7 @@
                       </p:stCondLst>
                       <p:childTnLst>
                         <p:par>
-                          <p:cTn id="6" presetID="10" presetClass="entr" presetSubtype="0" fill="hold" grpId="0" nodeType="afterEffect">
+                          <p:cTn id="8" presetID="23" presetClass="entr" presetSubtype="16" fill="hold" grpId="0" nodeType="afterEffect">
                             <p:stCondLst>
                               <p:cond delay="0"/>
                             </p:stCondLst>
@@ -12351,7 +12690,88 @@
                                     </p:stCondLst>
                                   </p:cTn>
                                   <p:tgtEl>
-                                    <p:spTgt spid="4"/>
+                                    <p:spTgt spid="3"/>
+                                  </p:tgtEl>
+                                  <p:attrNameLst>
+                                    <p:attrName>style.visibility</p:attrName>
+                                  </p:attrNameLst>
+                                </p:cBhvr>
+                                <p:to>
+                                  <p:strVal val="visible"/>
+                                </p:to>
+                              </p:set>
+                              <p:anim calcmode="lin" valueType="num">
+                                <p:cBhvr additive="base">
+                                  <p:cTn id="5" dur="600" fill="hold"/>
+                                  <p:tgtEl>
+                                    <p:spTgt spid="3"/>
+                                  </p:tgtEl>
+                                  <p:attrNameLst>
+                                    <p:attrName>ppt_w</p:attrName>
+                                  </p:attrNameLst>
+                                </p:cBhvr>
+                                <p:tavLst>
+                                  <p:tav tm="0">
+                                    <p:val>
+                                      <p:fltVal val="0.3"/>
+                                    </p:val>
+                                  </p:tav>
+                                  <p:tav tm="100000">
+                                    <p:val>
+                                      <p:fltVal val="1"/>
+                                    </p:val>
+                                  </p:tav>
+                                </p:tavLst>
+                              </p:anim>
+                              <p:anim calcmode="lin" valueType="num">
+                                <p:cBhvr additive="base">
+                                  <p:cTn id="6" dur="600" fill="hold"/>
+                                  <p:tgtEl>
+                                    <p:spTgt spid="3"/>
+                                  </p:tgtEl>
+                                  <p:attrNameLst>
+                                    <p:attrName>ppt_h</p:attrName>
+                                  </p:attrNameLst>
+                                </p:cBhvr>
+                                <p:tavLst>
+                                  <p:tav tm="0">
+                                    <p:val>
+                                      <p:fltVal val="0.3"/>
+                                    </p:val>
+                                  </p:tav>
+                                  <p:tav tm="100000">
+                                    <p:val>
+                                      <p:fltVal val="1"/>
+                                    </p:val>
+                                  </p:tav>
+                                </p:tavLst>
+                              </p:anim>
+                              <p:animEffect transition="in" filter="fade">
+                                <p:cBhvr>
+                                  <p:cTn id="7" dur="600"/>
+                                  <p:tgtEl>
+                                    <p:spTgt spid="3"/>
+                                  </p:tgtEl>
+                                </p:cBhvr>
+                              </p:animEffect>
+                            </p:childTnLst>
+                          </p:cTn>
+                        </p:par>
+                        <p:par>
+                          <p:cTn id="11" presetID="10" presetClass="entr" presetSubtype="0" fill="hold" grpId="0" nodeType="afterEffect">
+                            <p:stCondLst>
+                              <p:cond delay="350"/>
+                            </p:stCondLst>
+                            <p:childTnLst>
+                              <p:set>
+                                <p:cBhvr>
+                                  <p:cTn id="9" dur="1" fill="hold">
+                                    <p:stCondLst>
+                                      <p:cond delay="0"/>
+                                    </p:stCondLst>
+                                  </p:cTn>
+                                  <p:tgtEl>
+                                    <p:spTgt spid="5"/>
                                   </p:tgtEl>
                                   <p:attrNameLst>
                                     <p:attrName>style.visibility</p:attrName>
@@ -12363,9 +12783,9 @@
                               </p:set>
                               <p:animEffect transition="in" filter="fade">
                                 <p:cBhvr>
-                                  <p:cTn id="5" dur="400"/>
+                                  <p:cTn id="10" dur="400"/>
                                   <p:tgtEl>
-                                    <p:spTgt spid="4"/>
+                                    <p:spTgt spid="5"/>
                                   </p:tgtEl>
                                 </p:cBhvr>
                               </p:animEffect>
@@ -14156,15 +14576,39 @@
           </a:p>
         </p:txBody>
       </p:sp>
-      <p:sp>
-        <p:nvSpPr>
-          <p:cNvPr id="3" name="Rectangle 2"/>
+      <p:pic>
+        <p:nvPicPr>
+          <p:cNvPr id="3" name="Picture 2" descr="LOGO-OCEO.png"/>
+          <p:cNvPicPr>
+            <a:picLocks noChangeAspect="1"/>
+          </p:cNvPicPr>
+          <p:nvPr/>
+        </p:nvPicPr>
+        <p:blipFill>
+          <a:blip r:embed="rId2"/>
+          <a:stretch>
+            <a:fillRect/>
+          </a:stretch>
+        </p:blipFill>
+        <p:spPr>
+          <a:xfrm>
+            <a:off x="868680" y="777240"/>
+            <a:ext cx="2468880" cy="1991869"/>
+          </a:xfrm>
+          <a:prstGeom prst="rect">
+            <a:avLst/>
+          </a:prstGeom>
+        </p:spPr>
+      </p:pic>
+      <p:sp>
+        <p:nvSpPr>
+          <p:cNvPr id="4" name="Rectangle 3"/>
           <p:cNvSpPr/>
           <p:nvPr/>
         </p:nvSpPr>
         <p:spPr>
           <a:xfrm>
-            <a:off x="914400" y="2651760"/>
+            <a:off x="914400" y="3977639"/>
             <a:ext cx="2011680" cy="38100"/>
           </a:xfrm>
           <a:prstGeom prst="rect">
@@ -14202,13 +14646,13 @@
       </p:sp>
       <p:sp>
         <p:nvSpPr>
-          <p:cNvPr id="4" name="TextBox 3"/>
+          <p:cNvPr id="5" name="TextBox 4"/>
           <p:cNvSpPr txBox="1"/>
           <p:nvPr/>
         </p:nvSpPr>
         <p:spPr>
           <a:xfrm>
-            <a:off x="896112" y="2880360"/>
+            <a:off x="896112" y="4206240"/>
             <a:ext cx="10058400" cy="2194560"/>
           </a:xfrm>
           <a:prstGeom prst="rect">
@@ -14292,7 +14736,7 @@
                       </p:stCondLst>
                       <p:childTnLst>
                         <p:par>
-                          <p:cTn id="6" presetID="10" presetClass="entr" presetSubtype="0" fill="hold" grpId="0" nodeType="afterEffect">
+                          <p:cTn id="8" presetID="23" presetClass="entr" presetSubtype="16" fill="hold" grpId="0" nodeType="afterEffect">
                             <p:stCondLst>
                               <p:cond delay="0"/>
                             </p:stCondLst>
@@ -14305,7 +14749,88 @@
                                     </p:stCondLst>
                                   </p:cTn>
                                   <p:tgtEl>
-                                    <p:spTgt spid="4"/>
+                                    <p:spTgt spid="3"/>
+                                  </p:tgtEl>
+                                  <p:attrNameLst>
+                                    <p:attrName>style.visibility</p:attrName>
+                                  </p:attrNameLst>
+                                </p:cBhvr>
+                                <p:to>
+                                  <p:strVal val="visible"/>
+                                </p:to>
+                              </p:set>
+                              <p:anim calcmode="lin" valueType="num">
+                                <p:cBhvr additive="base">
+                                  <p:cTn id="5" dur="600" fill="hold"/>
+                                  <p:tgtEl>
+                                    <p:spTgt spid="3"/>
+                                  </p:tgtEl>
+                                  <p:attrNameLst>
+                                    <p:attrName>ppt_w</p:attrName>
+                                  </p:attrNameLst>
+                                </p:cBhvr>
+                                <p:tavLst>
+                                  <p:tav tm="0">
+                                    <p:val>
+                                      <p:fltVal val="0.3"/>
+                                    </p:val>
+                                  </p:tav>
+                                  <p:tav tm="100000">
+                                    <p:val>
+                                      <p:fltVal val="1"/>
+                                    </p:val>
+                                  </p:tav>
+                                </p:tavLst>
+                              </p:anim>
+                              <p:anim calcmode="lin" valueType="num">
+                                <p:cBhvr additive="base">
+                                  <p:cTn id="6" dur="600" fill="hold"/>
+                                  <p:tgtEl>
+                                    <p:spTgt spid="3"/>
+                                  </p:tgtEl>
+                                  <p:attrNameLst>
+                                    <p:attrName>ppt_h</p:attrName>
+                                  </p:attrNameLst>
+                                </p:cBhvr>
+                                <p:tavLst>
+                                  <p:tav tm="0">
+                                    <p:val>
+                                      <p:fltVal val="0.3"/>
+                                    </p:val>
+                                  </p:tav>
+                                  <p:tav tm="100000">
+                                    <p:val>
+                                      <p:fltVal val="1"/>
+                                    </p:val>
+                                  </p:tav>
+                                </p:tavLst>
+                              </p:anim>
+                              <p:animEffect transition="in" filter="fade">
+                                <p:cBhvr>
+                                  <p:cTn id="7" dur="600"/>
+                                  <p:tgtEl>
+                                    <p:spTgt spid="3"/>
+                                  </p:tgtEl>
+                                </p:cBhvr>
+                              </p:animEffect>
+                            </p:childTnLst>
+                          </p:cTn>
+                        </p:par>
+                        <p:par>
+                          <p:cTn id="11" presetID="10" presetClass="entr" presetSubtype="0" fill="hold" grpId="0" nodeType="afterEffect">
+                            <p:stCondLst>
+                              <p:cond delay="350"/>
+                            </p:stCondLst>
+                            <p:childTnLst>
+                              <p:set>
+                                <p:cBhvr>
+                                  <p:cTn id="9" dur="1" fill="hold">
+                                    <p:stCondLst>
+                                      <p:cond delay="0"/>
+                                    </p:stCondLst>
+                                  </p:cTn>
+                                  <p:tgtEl>
+                                    <p:spTgt spid="5"/>
                                   </p:tgtEl>
                                   <p:attrNameLst>
                                     <p:attrName>style.visibility</p:attrName>
@@ -14317,9 +14842,9 @@
                               </p:set>
                               <p:animEffect transition="in" filter="fade">
                                 <p:cBhvr>
-                                  <p:cTn id="5" dur="400"/>
+                                  <p:cTn id="10" dur="400"/>
                                   <p:tgtEl>
-                                    <p:spTgt spid="4"/>
+                                    <p:spTgt spid="5"/>
                                   </p:tgtEl>
                                 </p:cBhvr>
                               </p:animEffect>

</xml_diff>